<commit_message>
Add held-out feature heatmap examples
</commit_message>
<xml_diff>
--- a/presentations/face_sae_research_update.pptx
+++ b/presentations/face_sae_research_update.pptx
@@ -15,6 +15,7 @@
     <p:sldId id="263" r:id="rId15"/>
     <p:sldId id="264" r:id="rId16"/>
     <p:sldId id="265" r:id="rId17"/>
+    <p:sldId id="266" r:id="rId18"/>
   </p:sldIdLst>
   <p:sldSz cx="12191695" cy="6858000" type="screen4x3"/>
   <p:notesSz cx="6858000" cy="9144000"/>
@@ -537,6 +538,76 @@
 </file>
 
 <file path=ppt/notesSlides/notesSlide10.xml><?xml version="1.0" encoding="utf-8"?>
+<p:notes xmlns:a="http://schemas.openxmlformats.org/drawingml/2006/main" xmlns:p="http://schemas.openxmlformats.org/presentationml/2006/main" xmlns:r="http://schemas.openxmlformats.org/officeDocument/2006/relationships">
+  <p:cSld>
+    <p:spTree>
+      <p:nvGrpSpPr>
+        <p:cNvPr id="1" name=""/>
+        <p:cNvGrpSpPr/>
+        <p:nvPr/>
+      </p:nvGrpSpPr>
+      <p:grpSpPr>
+        <a:xfrm>
+          <a:off x="0" y="0"/>
+          <a:ext cx="0" cy="0"/>
+          <a:chOff x="0" y="0"/>
+          <a:chExt cx="0" cy="0"/>
+        </a:xfrm>
+      </p:grpSpPr>
+      <p:sp>
+        <p:nvSpPr>
+          <p:cNvPr id="2" name="Slide Image Placeholder 1"/>
+          <p:cNvSpPr>
+            <a:spLocks noGrp="1"/>
+          </p:cNvSpPr>
+          <p:nvPr>
+            <p:ph type="sldImg" idx="2"/>
+          </p:nvPr>
+        </p:nvSpPr>
+        <p:spPr/>
+      </p:sp>
+      <p:sp>
+        <p:nvSpPr>
+          <p:cNvPr id="3" name="Notes Placeholder 2"/>
+          <p:cNvSpPr>
+            <a:spLocks noGrp="1"/>
+          </p:cNvSpPr>
+          <p:nvPr>
+            <p:ph type="body" idx="3" sz="quarter"/>
+          </p:nvPr>
+        </p:nvSpPr>
+        <p:spPr/>
+        <p:txBody>
+          <a:bodyPr/>
+          <a:lstStyle/>
+          <a:p>
+            <a:r>
+              <a:t>These are illustrative high-activation examples, selected from eligible held-out test portraits for display. The heatmap is normalized within each detected face box. The examples help inspect spatial alignment, but do not estimate how often a feature localizes to a part; those estimates are in the preceding table and use all eligible test images. Boxes are automatic and unreviewed.</a:t>
+            </a:r>
+          </a:p>
+        </p:txBody>
+      </p:sp>
+      <p:sp>
+        <p:nvSpPr>
+          <p:cNvPr id="4" name="Slide Number Placeholder 3"/>
+          <p:cNvSpPr>
+            <a:spLocks noGrp="1"/>
+          </p:cNvSpPr>
+          <p:nvPr>
+            <p:ph type="sldNum" idx="5" sz="quarter"/>
+          </p:nvPr>
+        </p:nvSpPr>
+        <p:spPr/>
+      </p:sp>
+    </p:spTree>
+  </p:cSld>
+  <p:clrMapOvr>
+    <a:masterClrMapping/>
+  </p:clrMapOvr>
+</p:notes>
+</file>
+
+<file path=ppt/notesSlides/notesSlide11.xml><?xml version="1.0" encoding="utf-8"?>
 <p:notes xmlns:a="http://schemas.openxmlformats.org/drawingml/2006/main" xmlns:p="http://schemas.openxmlformats.org/presentationml/2006/main" xmlns:r="http://schemas.openxmlformats.org/officeDocument/2006/relationships">
   <p:cSld>
     <p:spTree>
@@ -4453,7 +4524,7 @@
               </a:defRPr>
             </a:pPr>
             <a:r>
-              <a:t>What we can claim—and what comes next</a:t>
+              <a:t>Jet heatmaps show example feature locations</a:t>
             </a:r>
           </a:p>
         </p:txBody>
@@ -4489,7 +4560,7 @@
               </a:defRPr>
             </a:pPr>
             <a:r>
-              <a:t>The evidence supports a useful localization result, with clear limits</a:t>
+              <a:t>Held-out portraits · cyan = detected face · yellow = annotated part</a:t>
             </a:r>
           </a:p>
         </p:txBody>
@@ -4569,6 +4640,554 @@
             </a:pPr>
             <a:r>
               <a:t>10</a:t>
+            </a:r>
+          </a:p>
+        </p:txBody>
+      </p:sp>
+      <p:pic>
+        <p:nvPicPr>
+          <p:cNvPr id="7" name="Picture 6" descr="feature_part_examples.jpg"/>
+          <p:cNvPicPr>
+            <a:picLocks noChangeAspect="1"/>
+          </p:cNvPicPr>
+          <p:nvPr/>
+        </p:nvPicPr>
+        <p:blipFill>
+          <a:blip r:embed="rId3"/>
+          <a:stretch>
+            <a:fillRect/>
+          </a:stretch>
+        </p:blipFill>
+        <p:spPr>
+          <a:xfrm>
+            <a:off x="964497" y="1536192"/>
+            <a:ext cx="4426085" cy="4800600"/>
+          </a:xfrm>
+          <a:prstGeom prst="rect">
+            <a:avLst/>
+          </a:prstGeom>
+        </p:spPr>
+      </p:pic>
+      <p:sp>
+        <p:nvSpPr>
+          <p:cNvPr id="8" name="TextBox 7"/>
+          <p:cNvSpPr txBox="1"/>
+          <p:nvPr/>
+        </p:nvSpPr>
+        <p:spPr>
+          <a:xfrm>
+            <a:off x="6080760" y="1737360"/>
+            <a:ext cx="5212080" cy="347472"/>
+          </a:xfrm>
+          <a:prstGeom prst="rect">
+            <a:avLst/>
+          </a:prstGeom>
+          <a:noFill/>
+        </p:spPr>
+        <p:txBody>
+          <a:bodyPr wrap="square" lIns="18288" rIns="18288" tIns="9144" bIns="9144">
+            <a:spAutoFit/>
+          </a:bodyPr>
+          <a:lstStyle/>
+          <a:p>
+            <a:pPr algn="l">
+              <a:defRPr sz="1900" b="1">
+                <a:solidFill>
+                  <a:srgbClr val="17263A"/>
+                </a:solidFill>
+                <a:latin typeface="Aptos"/>
+              </a:defRPr>
+            </a:pPr>
+            <a:r>
+              <a:t>Feature 1664</a:t>
+            </a:r>
+          </a:p>
+        </p:txBody>
+      </p:sp>
+      <p:sp>
+        <p:nvSpPr>
+          <p:cNvPr id="9" name="TextBox 8"/>
+          <p:cNvSpPr txBox="1"/>
+          <p:nvPr/>
+        </p:nvSpPr>
+        <p:spPr>
+          <a:xfrm>
+            <a:off x="6099048" y="2176272"/>
+            <a:ext cx="5166360" cy="960120"/>
+          </a:xfrm>
+          <a:prstGeom prst="rect">
+            <a:avLst/>
+          </a:prstGeom>
+          <a:noFill/>
+        </p:spPr>
+        <p:txBody>
+          <a:bodyPr wrap="square" lIns="18288" rIns="18288" tIns="9144" bIns="9144">
+            <a:spAutoFit/>
+          </a:bodyPr>
+          <a:lstStyle/>
+          <a:p>
+            <a:pPr algn="l">
+              <a:defRPr sz="1600" b="0">
+                <a:solidFill>
+                  <a:srgbClr val="283240"/>
+                </a:solidFill>
+                <a:latin typeface="Aptos"/>
+              </a:defRPr>
+            </a:pPr>
+            <a:r>
+              <a:t>The strongest activation in this example falls around the annotated nose box, consistent with its high held-out nose contrast.</a:t>
+            </a:r>
+          </a:p>
+        </p:txBody>
+      </p:sp>
+      <p:sp>
+        <p:nvSpPr>
+          <p:cNvPr id="10" name="TextBox 9"/>
+          <p:cNvSpPr txBox="1"/>
+          <p:nvPr/>
+        </p:nvSpPr>
+        <p:spPr>
+          <a:xfrm>
+            <a:off x="6080760" y="3520440"/>
+            <a:ext cx="5212080" cy="347472"/>
+          </a:xfrm>
+          <a:prstGeom prst="rect">
+            <a:avLst/>
+          </a:prstGeom>
+          <a:noFill/>
+        </p:spPr>
+        <p:txBody>
+          <a:bodyPr wrap="square" lIns="18288" rIns="18288" tIns="9144" bIns="9144">
+            <a:spAutoFit/>
+          </a:bodyPr>
+          <a:lstStyle/>
+          <a:p>
+            <a:pPr algn="l">
+              <a:defRPr sz="1900" b="1">
+                <a:solidFill>
+                  <a:srgbClr val="17263A"/>
+                </a:solidFill>
+                <a:latin typeface="Aptos"/>
+              </a:defRPr>
+            </a:pPr>
+            <a:r>
+              <a:t>Features 527 and 3725</a:t>
+            </a:r>
+          </a:p>
+        </p:txBody>
+      </p:sp>
+      <p:sp>
+        <p:nvSpPr>
+          <p:cNvPr id="11" name="TextBox 10"/>
+          <p:cNvSpPr txBox="1"/>
+          <p:nvPr/>
+        </p:nvSpPr>
+        <p:spPr>
+          <a:xfrm>
+            <a:off x="6099048" y="3959352"/>
+            <a:ext cx="5166360" cy="960120"/>
+          </a:xfrm>
+          <a:prstGeom prst="rect">
+            <a:avLst/>
+          </a:prstGeom>
+          <a:noFill/>
+        </p:spPr>
+        <p:txBody>
+          <a:bodyPr wrap="square" lIns="18288" rIns="18288" tIns="9144" bIns="9144">
+            <a:spAutoFit/>
+          </a:bodyPr>
+          <a:lstStyle/>
+          <a:p>
+            <a:pPr algn="l">
+              <a:defRPr sz="1600" b="0">
+                <a:solidFill>
+                  <a:srgbClr val="283240"/>
+                </a:solidFill>
+                <a:latin typeface="Aptos"/>
+              </a:defRPr>
+            </a:pPr>
+            <a:r>
+              <a:t>Their heatmaps spread across more of the face, matching their positive contrasts in several regions rather than a single-part pattern.</a:t>
+            </a:r>
+          </a:p>
+        </p:txBody>
+      </p:sp>
+      <p:sp>
+        <p:nvSpPr>
+          <p:cNvPr id="12" name="Rounded Rectangle 11"/>
+          <p:cNvSpPr/>
+          <p:nvPr/>
+        </p:nvSpPr>
+        <p:spPr>
+          <a:xfrm>
+            <a:off x="6080760" y="5349240"/>
+            <a:ext cx="5074920" cy="749808"/>
+          </a:xfrm>
+          <a:prstGeom prst="roundRect">
+            <a:avLst/>
+          </a:prstGeom>
+          <a:solidFill>
+            <a:srgbClr val="E8F4F3"/>
+          </a:solidFill>
+          <a:ln>
+            <a:solidFill>
+              <a:srgbClr val="DEE6EC"/>
+            </a:solidFill>
+          </a:ln>
+        </p:spPr>
+        <p:style>
+          <a:lnRef idx="1">
+            <a:schemeClr val="accent1"/>
+          </a:lnRef>
+          <a:fillRef idx="3">
+            <a:schemeClr val="accent1"/>
+          </a:fillRef>
+          <a:effectRef idx="2">
+            <a:schemeClr val="accent1"/>
+          </a:effectRef>
+          <a:fontRef idx="minor">
+            <a:schemeClr val="lt1"/>
+          </a:fontRef>
+        </p:style>
+        <p:txBody>
+          <a:bodyPr rtlCol="0" anchor="ctr"/>
+          <a:lstStyle/>
+          <a:p>
+            <a:pPr algn="ctr"/>
+          </a:p>
+        </p:txBody>
+      </p:sp>
+      <p:sp>
+        <p:nvSpPr>
+          <p:cNvPr id="13" name="Rectangle 12"/>
+          <p:cNvSpPr/>
+          <p:nvPr/>
+        </p:nvSpPr>
+        <p:spPr>
+          <a:xfrm>
+            <a:off x="6080760" y="5349240"/>
+            <a:ext cx="64008" cy="749808"/>
+          </a:xfrm>
+          <a:prstGeom prst="rect">
+            <a:avLst/>
+          </a:prstGeom>
+          <a:solidFill>
+            <a:srgbClr val="008F93"/>
+          </a:solidFill>
+          <a:ln>
+            <a:noFill/>
+          </a:ln>
+        </p:spPr>
+        <p:style>
+          <a:lnRef idx="1">
+            <a:schemeClr val="accent1"/>
+          </a:lnRef>
+          <a:fillRef idx="3">
+            <a:schemeClr val="accent1"/>
+          </a:fillRef>
+          <a:effectRef idx="2">
+            <a:schemeClr val="accent1"/>
+          </a:effectRef>
+          <a:fontRef idx="minor">
+            <a:schemeClr val="lt1"/>
+          </a:fontRef>
+        </p:style>
+        <p:txBody>
+          <a:bodyPr rtlCol="0" anchor="ctr"/>
+          <a:lstStyle/>
+          <a:p>
+            <a:pPr algn="ctr"/>
+          </a:p>
+        </p:txBody>
+      </p:sp>
+      <p:sp>
+        <p:nvSpPr>
+          <p:cNvPr id="14" name="TextBox 13"/>
+          <p:cNvSpPr txBox="1"/>
+          <p:nvPr/>
+        </p:nvSpPr>
+        <p:spPr>
+          <a:xfrm>
+            <a:off x="6281928" y="5422392"/>
+            <a:ext cx="4709159" cy="219456"/>
+          </a:xfrm>
+          <a:prstGeom prst="rect">
+            <a:avLst/>
+          </a:prstGeom>
+          <a:noFill/>
+        </p:spPr>
+        <p:txBody>
+          <a:bodyPr wrap="square" lIns="18288" rIns="18288" tIns="9144" bIns="9144">
+            <a:spAutoFit/>
+          </a:bodyPr>
+          <a:lstStyle/>
+          <a:p>
+            <a:pPr algn="l">
+              <a:defRPr sz="1500" b="1">
+                <a:solidFill>
+                  <a:srgbClr val="17263A"/>
+                </a:solidFill>
+                <a:latin typeface="Aptos"/>
+              </a:defRPr>
+            </a:pPr>
+            <a:r>
+              <a:t>How to read these panels</a:t>
+            </a:r>
+          </a:p>
+        </p:txBody>
+      </p:sp>
+      <p:sp>
+        <p:nvSpPr>
+          <p:cNvPr id="15" name="TextBox 14"/>
+          <p:cNvSpPr txBox="1"/>
+          <p:nvPr/>
+        </p:nvSpPr>
+        <p:spPr>
+          <a:xfrm>
+            <a:off x="6281928" y="5687568"/>
+            <a:ext cx="4709159" cy="365759"/>
+          </a:xfrm>
+          <a:prstGeom prst="rect">
+            <a:avLst/>
+          </a:prstGeom>
+          <a:noFill/>
+        </p:spPr>
+        <p:txBody>
+          <a:bodyPr wrap="square" lIns="18288" rIns="18288" tIns="9144" bIns="9144">
+            <a:spAutoFit/>
+          </a:bodyPr>
+          <a:lstStyle/>
+          <a:p>
+            <a:pPr algn="l">
+              <a:defRPr sz="1200" b="0">
+                <a:solidFill>
+                  <a:srgbClr val="283240"/>
+                </a:solidFill>
+                <a:latin typeface="Aptos"/>
+              </a:defRPr>
+            </a:pPr>
+            <a:r>
+              <a:t>Examples selected for visibility; aggregate table uses the full held-out sample.</a:t>
+            </a:r>
+          </a:p>
+        </p:txBody>
+      </p:sp>
+    </p:spTree>
+  </p:cSld>
+  <p:clrMapOvr>
+    <a:masterClrMapping/>
+  </p:clrMapOvr>
+</p:sld>
+</file>
+
+<file path=ppt/slides/slide11.xml><?xml version="1.0" encoding="utf-8"?>
+<p:sld xmlns:a="http://schemas.openxmlformats.org/drawingml/2006/main" xmlns:p="http://schemas.openxmlformats.org/presentationml/2006/main" xmlns:r="http://schemas.openxmlformats.org/officeDocument/2006/relationships">
+  <p:cSld>
+    <p:bg>
+      <p:bgPr>
+        <a:solidFill>
+          <a:srgbClr val="F9FAFC"/>
+        </a:solidFill>
+        <a:effectLst/>
+      </p:bgPr>
+    </p:bg>
+    <p:spTree>
+      <p:nvGrpSpPr>
+        <p:cNvPr id="1" name=""/>
+        <p:cNvGrpSpPr/>
+        <p:nvPr/>
+      </p:nvGrpSpPr>
+      <p:grpSpPr/>
+      <p:sp>
+        <p:nvSpPr>
+          <p:cNvPr id="2" name="Rectangle 1"/>
+          <p:cNvSpPr/>
+          <p:nvPr/>
+        </p:nvSpPr>
+        <p:spPr>
+          <a:xfrm>
+            <a:off x="0" y="0"/>
+            <a:ext cx="146304" cy="6858000"/>
+          </a:xfrm>
+          <a:prstGeom prst="rect">
+            <a:avLst/>
+          </a:prstGeom>
+          <a:solidFill>
+            <a:srgbClr val="008F93"/>
+          </a:solidFill>
+          <a:ln>
+            <a:noFill/>
+          </a:ln>
+        </p:spPr>
+        <p:style>
+          <a:lnRef idx="1">
+            <a:schemeClr val="accent1"/>
+          </a:lnRef>
+          <a:fillRef idx="3">
+            <a:schemeClr val="accent1"/>
+          </a:fillRef>
+          <a:effectRef idx="2">
+            <a:schemeClr val="accent1"/>
+          </a:effectRef>
+          <a:fontRef idx="minor">
+            <a:schemeClr val="lt1"/>
+          </a:fontRef>
+        </p:style>
+        <p:txBody>
+          <a:bodyPr rtlCol="0" anchor="ctr"/>
+          <a:lstStyle/>
+          <a:p>
+            <a:pPr algn="ctr"/>
+          </a:p>
+        </p:txBody>
+      </p:sp>
+      <p:sp>
+        <p:nvSpPr>
+          <p:cNvPr id="3" name="TextBox 2"/>
+          <p:cNvSpPr txBox="1"/>
+          <p:nvPr/>
+        </p:nvSpPr>
+        <p:spPr>
+          <a:xfrm>
+            <a:off x="566928" y="310896"/>
+            <a:ext cx="10972800" cy="530352"/>
+          </a:xfrm>
+          <a:prstGeom prst="rect">
+            <a:avLst/>
+          </a:prstGeom>
+          <a:noFill/>
+        </p:spPr>
+        <p:txBody>
+          <a:bodyPr wrap="square" lIns="18288" rIns="18288" tIns="9144" bIns="9144">
+            <a:spAutoFit/>
+          </a:bodyPr>
+          <a:lstStyle/>
+          <a:p>
+            <a:pPr algn="l">
+              <a:defRPr sz="2700" b="1">
+                <a:solidFill>
+                  <a:srgbClr val="17263A"/>
+                </a:solidFill>
+                <a:latin typeface="Aptos"/>
+              </a:defRPr>
+            </a:pPr>
+            <a:r>
+              <a:t>What we can claim—and what comes next</a:t>
+            </a:r>
+          </a:p>
+        </p:txBody>
+      </p:sp>
+      <p:sp>
+        <p:nvSpPr>
+          <p:cNvPr id="4" name="TextBox 3"/>
+          <p:cNvSpPr txBox="1"/>
+          <p:nvPr/>
+        </p:nvSpPr>
+        <p:spPr>
+          <a:xfrm>
+            <a:off x="594360" y="896112"/>
+            <a:ext cx="10972800" cy="347472"/>
+          </a:xfrm>
+          <a:prstGeom prst="rect">
+            <a:avLst/>
+          </a:prstGeom>
+          <a:noFill/>
+        </p:spPr>
+        <p:txBody>
+          <a:bodyPr wrap="square" lIns="18288" rIns="18288" tIns="9144" bIns="9144">
+            <a:spAutoFit/>
+          </a:bodyPr>
+          <a:lstStyle/>
+          <a:p>
+            <a:pPr algn="l">
+              <a:defRPr sz="1300" b="0">
+                <a:solidFill>
+                  <a:srgbClr val="66717F"/>
+                </a:solidFill>
+                <a:latin typeface="Aptos"/>
+              </a:defRPr>
+            </a:pPr>
+            <a:r>
+              <a:t>The evidence supports a useful localization result, with clear limits</a:t>
+            </a:r>
+          </a:p>
+        </p:txBody>
+      </p:sp>
+      <p:sp>
+        <p:nvSpPr>
+          <p:cNvPr id="5" name="Rectangle 4"/>
+          <p:cNvSpPr/>
+          <p:nvPr/>
+        </p:nvSpPr>
+        <p:spPr>
+          <a:xfrm>
+            <a:off x="594360" y="1353312"/>
+            <a:ext cx="10972800" cy="16459"/>
+          </a:xfrm>
+          <a:prstGeom prst="rect">
+            <a:avLst/>
+          </a:prstGeom>
+          <a:solidFill>
+            <a:srgbClr val="D2DCE4"/>
+          </a:solidFill>
+          <a:ln>
+            <a:noFill/>
+          </a:ln>
+        </p:spPr>
+        <p:style>
+          <a:lnRef idx="1">
+            <a:schemeClr val="accent1"/>
+          </a:lnRef>
+          <a:fillRef idx="3">
+            <a:schemeClr val="accent1"/>
+          </a:fillRef>
+          <a:effectRef idx="2">
+            <a:schemeClr val="accent1"/>
+          </a:effectRef>
+          <a:fontRef idx="minor">
+            <a:schemeClr val="lt1"/>
+          </a:fontRef>
+        </p:style>
+        <p:txBody>
+          <a:bodyPr rtlCol="0" anchor="ctr"/>
+          <a:lstStyle/>
+          <a:p>
+            <a:pPr algn="ctr"/>
+          </a:p>
+        </p:txBody>
+      </p:sp>
+      <p:sp>
+        <p:nvSpPr>
+          <p:cNvPr id="6" name="TextBox 5"/>
+          <p:cNvSpPr txBox="1"/>
+          <p:nvPr/>
+        </p:nvSpPr>
+        <p:spPr>
+          <a:xfrm>
+            <a:off x="11155680" y="6510528"/>
+            <a:ext cx="320040" cy="182880"/>
+          </a:xfrm>
+          <a:prstGeom prst="rect">
+            <a:avLst/>
+          </a:prstGeom>
+          <a:noFill/>
+        </p:spPr>
+        <p:txBody>
+          <a:bodyPr wrap="square" lIns="18288" rIns="18288" tIns="9144" bIns="9144">
+            <a:spAutoFit/>
+          </a:bodyPr>
+          <a:lstStyle/>
+          <a:p>
+            <a:pPr algn="r">
+              <a:defRPr sz="900" b="0">
+                <a:solidFill>
+                  <a:srgbClr val="66717F"/>
+                </a:solidFill>
+                <a:latin typeface="Aptos"/>
+              </a:defRPr>
+            </a:pPr>
+            <a:r>
+              <a:t>11</a:t>
             </a:r>
           </a:p>
         </p:txBody>

</xml_diff>